<commit_message>
Correct paper data source attribution and fix pptx asset path
The original paper's experiments used a curated multi-source dataset
(Bloomberg, Yahoo, EODHD, FinnHub, Reddit), not yfinance. Updated the
report's architecture description and Challenge 2 to reflect this gap
between the paper's experimental pipeline and the open-source code
defaults. Also fixed build_pptx.py BASE path so assets resolve correctly
from any working directory.

Co-Authored-By: childeon <233520750+childeon@users.noreply.github.com>
</commit_message>
<xml_diff>
--- a/FinalProjectPresentation_v2.pptx
+++ b/FinalProjectPresentation_v2.pptx
@@ -5,13 +5,13 @@
     <p:sldMasterId id="2147483648" r:id="rId1"/>
   </p:sldMasterIdLst>
   <p:sldIdLst>
-    <p:sldId id="256" r:id="rId2"/>
-    <p:sldId id="257" r:id="rId3"/>
-    <p:sldId id="258" r:id="rId4"/>
-    <p:sldId id="259" r:id="rId5"/>
-    <p:sldId id="260" r:id="rId6"/>
+    <p:sldId id="256" r:id="rId7"/>
+    <p:sldId id="257" r:id="rId8"/>
+    <p:sldId id="258" r:id="rId9"/>
+    <p:sldId id="259" r:id="rId10"/>
+    <p:sldId id="260" r:id="rId11"/>
   </p:sldIdLst>
-  <p:sldSz cx="12192000" cy="6858000"/>
+  <p:sldSz cx="12191695" cy="6858000" type="screen4x3"/>
   <p:notesSz cx="6858000" cy="9144000"/>
   <p:defaultTextStyle>
     <a:defPPr>
@@ -108,22 +108,6 @@
       </a:defRPr>
     </a:lvl9pPr>
   </p:defaultTextStyle>
-  <p:extLst>
-    <p:ext uri="{EFAFB233-063F-42B5-8137-9DF3F51BA10A}">
-      <p15:sldGuideLst xmlns:p15="http://schemas.microsoft.com/office/powerpoint/2012/main">
-        <p15:guide id="1" orient="horz" pos="2160">
-          <p15:clr>
-            <a:srgbClr val="A4A3A4"/>
-          </p15:clr>
-        </p15:guide>
-        <p15:guide id="2" pos="2880">
-          <p15:clr>
-            <a:srgbClr val="A4A3A4"/>
-          </p15:clr>
-        </p15:guide>
-      </p15:sldGuideLst>
-    </p:ext>
-  </p:extLst>
 </p:presentation>
 </file>
 
@@ -165,9 +149,10 @@
           <a:lstStyle/>
           <a:p>
             <a:r>
-              <a:rPr lang="en-US"/>
+              <a:rPr lang="en-US" smtClean="0"/>
               <a:t>Click to edit Master title style</a:t>
             </a:r>
+            <a:endParaRPr lang="en-US"/>
           </a:p>
         </p:txBody>
       </p:sp>
@@ -283,9 +268,10 @@
           </a:lstStyle>
           <a:p>
             <a:r>
-              <a:rPr lang="en-US"/>
+              <a:rPr lang="en-US" smtClean="0"/>
               <a:t>Click to edit Master subtitle style</a:t>
             </a:r>
+            <a:endParaRPr lang="en-US"/>
           </a:p>
         </p:txBody>
       </p:sp>
@@ -306,7 +292,7 @@
           <a:p>
             <a:fld id="{5BCAD085-E8A6-8845-BD4E-CB4CCA059FC4}" type="datetimeFigureOut">
               <a:rPr lang="en-US" smtClean="0"/>
-              <a:t>5/2/26</a:t>
+              <a:t>1/27/13</a:t>
             </a:fld>
             <a:endParaRPr lang="en-US"/>
           </a:p>
@@ -400,9 +386,10 @@
           <a:lstStyle/>
           <a:p>
             <a:r>
-              <a:rPr lang="en-US"/>
+              <a:rPr lang="en-US" smtClean="0"/>
               <a:t>Click to edit Master title style</a:t>
             </a:r>
+            <a:endParaRPr lang="en-US"/>
           </a:p>
         </p:txBody>
       </p:sp>
@@ -423,37 +410,38 @@
           <a:p>
             <a:pPr lvl="0"/>
             <a:r>
-              <a:rPr lang="en-US"/>
+              <a:rPr lang="en-US" smtClean="0"/>
               <a:t>Click to edit Master text styles</a:t>
             </a:r>
           </a:p>
           <a:p>
             <a:pPr lvl="1"/>
             <a:r>
-              <a:rPr lang="en-US"/>
+              <a:rPr lang="en-US" smtClean="0"/>
               <a:t>Second level</a:t>
             </a:r>
           </a:p>
           <a:p>
             <a:pPr lvl="2"/>
             <a:r>
-              <a:rPr lang="en-US"/>
+              <a:rPr lang="en-US" smtClean="0"/>
               <a:t>Third level</a:t>
             </a:r>
           </a:p>
           <a:p>
             <a:pPr lvl="3"/>
             <a:r>
-              <a:rPr lang="en-US"/>
+              <a:rPr lang="en-US" smtClean="0"/>
               <a:t>Fourth level</a:t>
             </a:r>
           </a:p>
           <a:p>
             <a:pPr lvl="4"/>
             <a:r>
-              <a:rPr lang="en-US"/>
+              <a:rPr lang="en-US" smtClean="0"/>
               <a:t>Fifth level</a:t>
             </a:r>
+            <a:endParaRPr lang="en-US"/>
           </a:p>
         </p:txBody>
       </p:sp>
@@ -474,7 +462,7 @@
           <a:p>
             <a:fld id="{5BCAD085-E8A6-8845-BD4E-CB4CCA059FC4}" type="datetimeFigureOut">
               <a:rPr lang="en-US" smtClean="0"/>
-              <a:t>5/2/26</a:t>
+              <a:t>1/27/13</a:t>
             </a:fld>
             <a:endParaRPr lang="en-US"/>
           </a:p>
@@ -573,9 +561,10 @@
           <a:lstStyle/>
           <a:p>
             <a:r>
-              <a:rPr lang="en-US"/>
+              <a:rPr lang="en-US" smtClean="0"/>
               <a:t>Click to edit Master title style</a:t>
             </a:r>
+            <a:endParaRPr lang="en-US"/>
           </a:p>
         </p:txBody>
       </p:sp>
@@ -601,37 +590,38 @@
           <a:p>
             <a:pPr lvl="0"/>
             <a:r>
-              <a:rPr lang="en-US"/>
+              <a:rPr lang="en-US" smtClean="0"/>
               <a:t>Click to edit Master text styles</a:t>
             </a:r>
           </a:p>
           <a:p>
             <a:pPr lvl="1"/>
             <a:r>
-              <a:rPr lang="en-US"/>
+              <a:rPr lang="en-US" smtClean="0"/>
               <a:t>Second level</a:t>
             </a:r>
           </a:p>
           <a:p>
             <a:pPr lvl="2"/>
             <a:r>
-              <a:rPr lang="en-US"/>
+              <a:rPr lang="en-US" smtClean="0"/>
               <a:t>Third level</a:t>
             </a:r>
           </a:p>
           <a:p>
             <a:pPr lvl="3"/>
             <a:r>
-              <a:rPr lang="en-US"/>
+              <a:rPr lang="en-US" smtClean="0"/>
               <a:t>Fourth level</a:t>
             </a:r>
           </a:p>
           <a:p>
             <a:pPr lvl="4"/>
             <a:r>
-              <a:rPr lang="en-US"/>
+              <a:rPr lang="en-US" smtClean="0"/>
               <a:t>Fifth level</a:t>
             </a:r>
+            <a:endParaRPr lang="en-US"/>
           </a:p>
         </p:txBody>
       </p:sp>
@@ -652,7 +642,7 @@
           <a:p>
             <a:fld id="{5BCAD085-E8A6-8845-BD4E-CB4CCA059FC4}" type="datetimeFigureOut">
               <a:rPr lang="en-US" smtClean="0"/>
-              <a:t>5/2/26</a:t>
+              <a:t>1/27/13</a:t>
             </a:fld>
             <a:endParaRPr lang="en-US"/>
           </a:p>
@@ -746,9 +736,10 @@
           <a:lstStyle/>
           <a:p>
             <a:r>
-              <a:rPr lang="en-US"/>
+              <a:rPr lang="en-US" smtClean="0"/>
               <a:t>Click to edit Master title style</a:t>
             </a:r>
+            <a:endParaRPr lang="en-US"/>
           </a:p>
         </p:txBody>
       </p:sp>
@@ -769,37 +760,38 @@
           <a:p>
             <a:pPr lvl="0"/>
             <a:r>
-              <a:rPr lang="en-US"/>
+              <a:rPr lang="en-US" smtClean="0"/>
               <a:t>Click to edit Master text styles</a:t>
             </a:r>
           </a:p>
           <a:p>
             <a:pPr lvl="1"/>
             <a:r>
-              <a:rPr lang="en-US"/>
+              <a:rPr lang="en-US" smtClean="0"/>
               <a:t>Second level</a:t>
             </a:r>
           </a:p>
           <a:p>
             <a:pPr lvl="2"/>
             <a:r>
-              <a:rPr lang="en-US"/>
+              <a:rPr lang="en-US" smtClean="0"/>
               <a:t>Third level</a:t>
             </a:r>
           </a:p>
           <a:p>
             <a:pPr lvl="3"/>
             <a:r>
-              <a:rPr lang="en-US"/>
+              <a:rPr lang="en-US" smtClean="0"/>
               <a:t>Fourth level</a:t>
             </a:r>
           </a:p>
           <a:p>
             <a:pPr lvl="4"/>
             <a:r>
-              <a:rPr lang="en-US"/>
+              <a:rPr lang="en-US" smtClean="0"/>
               <a:t>Fifth level</a:t>
             </a:r>
+            <a:endParaRPr lang="en-US"/>
           </a:p>
         </p:txBody>
       </p:sp>
@@ -820,7 +812,7 @@
           <a:p>
             <a:fld id="{5BCAD085-E8A6-8845-BD4E-CB4CCA059FC4}" type="datetimeFigureOut">
               <a:rPr lang="en-US" smtClean="0"/>
-              <a:t>5/2/26</a:t>
+              <a:t>1/27/13</a:t>
             </a:fld>
             <a:endParaRPr lang="en-US"/>
           </a:p>
@@ -923,9 +915,10 @@
           </a:lstStyle>
           <a:p>
             <a:r>
-              <a:rPr lang="en-US"/>
+              <a:rPr lang="en-US" smtClean="0"/>
               <a:t>Click to edit Master title style</a:t>
             </a:r>
+            <a:endParaRPr lang="en-US"/>
           </a:p>
         </p:txBody>
       </p:sp>
@@ -1042,7 +1035,7 @@
           <a:p>
             <a:pPr lvl="0"/>
             <a:r>
-              <a:rPr lang="en-US"/>
+              <a:rPr lang="en-US" smtClean="0"/>
               <a:t>Click to edit Master text styles</a:t>
             </a:r>
           </a:p>
@@ -1065,7 +1058,7 @@
           <a:p>
             <a:fld id="{5BCAD085-E8A6-8845-BD4E-CB4CCA059FC4}" type="datetimeFigureOut">
               <a:rPr lang="en-US" smtClean="0"/>
-              <a:t>5/2/26</a:t>
+              <a:t>1/27/13</a:t>
             </a:fld>
             <a:endParaRPr lang="en-US"/>
           </a:p>
@@ -1159,9 +1152,10 @@
           <a:lstStyle/>
           <a:p>
             <a:r>
-              <a:rPr lang="en-US"/>
+              <a:rPr lang="en-US" smtClean="0"/>
               <a:t>Click to edit Master title style</a:t>
             </a:r>
+            <a:endParaRPr lang="en-US"/>
           </a:p>
         </p:txBody>
       </p:sp>
@@ -1215,37 +1209,38 @@
           <a:p>
             <a:pPr lvl="0"/>
             <a:r>
-              <a:rPr lang="en-US"/>
+              <a:rPr lang="en-US" smtClean="0"/>
               <a:t>Click to edit Master text styles</a:t>
             </a:r>
           </a:p>
           <a:p>
             <a:pPr lvl="1"/>
             <a:r>
-              <a:rPr lang="en-US"/>
+              <a:rPr lang="en-US" smtClean="0"/>
               <a:t>Second level</a:t>
             </a:r>
           </a:p>
           <a:p>
             <a:pPr lvl="2"/>
             <a:r>
-              <a:rPr lang="en-US"/>
+              <a:rPr lang="en-US" smtClean="0"/>
               <a:t>Third level</a:t>
             </a:r>
           </a:p>
           <a:p>
             <a:pPr lvl="3"/>
             <a:r>
-              <a:rPr lang="en-US"/>
+              <a:rPr lang="en-US" smtClean="0"/>
               <a:t>Fourth level</a:t>
             </a:r>
           </a:p>
           <a:p>
             <a:pPr lvl="4"/>
             <a:r>
-              <a:rPr lang="en-US"/>
+              <a:rPr lang="en-US" smtClean="0"/>
               <a:t>Fifth level</a:t>
             </a:r>
+            <a:endParaRPr lang="en-US"/>
           </a:p>
         </p:txBody>
       </p:sp>
@@ -1299,37 +1294,38 @@
           <a:p>
             <a:pPr lvl="0"/>
             <a:r>
-              <a:rPr lang="en-US"/>
+              <a:rPr lang="en-US" smtClean="0"/>
               <a:t>Click to edit Master text styles</a:t>
             </a:r>
           </a:p>
           <a:p>
             <a:pPr lvl="1"/>
             <a:r>
-              <a:rPr lang="en-US"/>
+              <a:rPr lang="en-US" smtClean="0"/>
               <a:t>Second level</a:t>
             </a:r>
           </a:p>
           <a:p>
             <a:pPr lvl="2"/>
             <a:r>
-              <a:rPr lang="en-US"/>
+              <a:rPr lang="en-US" smtClean="0"/>
               <a:t>Third level</a:t>
             </a:r>
           </a:p>
           <a:p>
             <a:pPr lvl="3"/>
             <a:r>
-              <a:rPr lang="en-US"/>
+              <a:rPr lang="en-US" smtClean="0"/>
               <a:t>Fourth level</a:t>
             </a:r>
           </a:p>
           <a:p>
             <a:pPr lvl="4"/>
             <a:r>
-              <a:rPr lang="en-US"/>
+              <a:rPr lang="en-US" smtClean="0"/>
               <a:t>Fifth level</a:t>
             </a:r>
+            <a:endParaRPr lang="en-US"/>
           </a:p>
         </p:txBody>
       </p:sp>
@@ -1350,7 +1346,7 @@
           <a:p>
             <a:fld id="{5BCAD085-E8A6-8845-BD4E-CB4CCA059FC4}" type="datetimeFigureOut">
               <a:rPr lang="en-US" smtClean="0"/>
-              <a:t>5/2/26</a:t>
+              <a:t>1/27/13</a:t>
             </a:fld>
             <a:endParaRPr lang="en-US"/>
           </a:p>
@@ -1448,9 +1444,10 @@
           </a:lstStyle>
           <a:p>
             <a:r>
-              <a:rPr lang="en-US"/>
+              <a:rPr lang="en-US" smtClean="0"/>
               <a:t>Click to edit Master title style</a:t>
             </a:r>
+            <a:endParaRPr lang="en-US"/>
           </a:p>
         </p:txBody>
       </p:sp>
@@ -1513,7 +1510,7 @@
           <a:p>
             <a:pPr lvl="0"/>
             <a:r>
-              <a:rPr lang="en-US"/>
+              <a:rPr lang="en-US" smtClean="0"/>
               <a:t>Click to edit Master text styles</a:t>
             </a:r>
           </a:p>
@@ -1569,37 +1566,38 @@
           <a:p>
             <a:pPr lvl="0"/>
             <a:r>
-              <a:rPr lang="en-US"/>
+              <a:rPr lang="en-US" smtClean="0"/>
               <a:t>Click to edit Master text styles</a:t>
             </a:r>
           </a:p>
           <a:p>
             <a:pPr lvl="1"/>
             <a:r>
-              <a:rPr lang="en-US"/>
+              <a:rPr lang="en-US" smtClean="0"/>
               <a:t>Second level</a:t>
             </a:r>
           </a:p>
           <a:p>
             <a:pPr lvl="2"/>
             <a:r>
-              <a:rPr lang="en-US"/>
+              <a:rPr lang="en-US" smtClean="0"/>
               <a:t>Third level</a:t>
             </a:r>
           </a:p>
           <a:p>
             <a:pPr lvl="3"/>
             <a:r>
-              <a:rPr lang="en-US"/>
+              <a:rPr lang="en-US" smtClean="0"/>
               <a:t>Fourth level</a:t>
             </a:r>
           </a:p>
           <a:p>
             <a:pPr lvl="4"/>
             <a:r>
-              <a:rPr lang="en-US"/>
+              <a:rPr lang="en-US" smtClean="0"/>
               <a:t>Fifth level</a:t>
             </a:r>
+            <a:endParaRPr lang="en-US"/>
           </a:p>
         </p:txBody>
       </p:sp>
@@ -1662,7 +1660,7 @@
           <a:p>
             <a:pPr lvl="0"/>
             <a:r>
-              <a:rPr lang="en-US"/>
+              <a:rPr lang="en-US" smtClean="0"/>
               <a:t>Click to edit Master text styles</a:t>
             </a:r>
           </a:p>
@@ -1718,37 +1716,38 @@
           <a:p>
             <a:pPr lvl="0"/>
             <a:r>
-              <a:rPr lang="en-US"/>
+              <a:rPr lang="en-US" smtClean="0"/>
               <a:t>Click to edit Master text styles</a:t>
             </a:r>
           </a:p>
           <a:p>
             <a:pPr lvl="1"/>
             <a:r>
-              <a:rPr lang="en-US"/>
+              <a:rPr lang="en-US" smtClean="0"/>
               <a:t>Second level</a:t>
             </a:r>
           </a:p>
           <a:p>
             <a:pPr lvl="2"/>
             <a:r>
-              <a:rPr lang="en-US"/>
+              <a:rPr lang="en-US" smtClean="0"/>
               <a:t>Third level</a:t>
             </a:r>
           </a:p>
           <a:p>
             <a:pPr lvl="3"/>
             <a:r>
-              <a:rPr lang="en-US"/>
+              <a:rPr lang="en-US" smtClean="0"/>
               <a:t>Fourth level</a:t>
             </a:r>
           </a:p>
           <a:p>
             <a:pPr lvl="4"/>
             <a:r>
-              <a:rPr lang="en-US"/>
+              <a:rPr lang="en-US" smtClean="0"/>
               <a:t>Fifth level</a:t>
             </a:r>
+            <a:endParaRPr lang="en-US"/>
           </a:p>
         </p:txBody>
       </p:sp>
@@ -1769,7 +1768,7 @@
           <a:p>
             <a:fld id="{5BCAD085-E8A6-8845-BD4E-CB4CCA059FC4}" type="datetimeFigureOut">
               <a:rPr lang="en-US" smtClean="0"/>
-              <a:t>5/2/26</a:t>
+              <a:t>1/27/13</a:t>
             </a:fld>
             <a:endParaRPr lang="en-US"/>
           </a:p>
@@ -1863,9 +1862,10 @@
           <a:lstStyle/>
           <a:p>
             <a:r>
-              <a:rPr lang="en-US"/>
+              <a:rPr lang="en-US" smtClean="0"/>
               <a:t>Click to edit Master title style</a:t>
             </a:r>
+            <a:endParaRPr lang="en-US"/>
           </a:p>
         </p:txBody>
       </p:sp>
@@ -1886,7 +1886,7 @@
           <a:p>
             <a:fld id="{5BCAD085-E8A6-8845-BD4E-CB4CCA059FC4}" type="datetimeFigureOut">
               <a:rPr lang="en-US" smtClean="0"/>
-              <a:t>5/2/26</a:t>
+              <a:t>1/27/13</a:t>
             </a:fld>
             <a:endParaRPr lang="en-US"/>
           </a:p>
@@ -1981,7 +1981,7 @@
           <a:p>
             <a:fld id="{5BCAD085-E8A6-8845-BD4E-CB4CCA059FC4}" type="datetimeFigureOut">
               <a:rPr lang="en-US" smtClean="0"/>
-              <a:t>5/2/26</a:t>
+              <a:t>1/27/13</a:t>
             </a:fld>
             <a:endParaRPr lang="en-US"/>
           </a:p>
@@ -2084,9 +2084,10 @@
           </a:lstStyle>
           <a:p>
             <a:r>
-              <a:rPr lang="en-US"/>
+              <a:rPr lang="en-US" smtClean="0"/>
               <a:t>Click to edit Master title style</a:t>
             </a:r>
+            <a:endParaRPr lang="en-US"/>
           </a:p>
         </p:txBody>
       </p:sp>
@@ -2140,37 +2141,38 @@
           <a:p>
             <a:pPr lvl="0"/>
             <a:r>
-              <a:rPr lang="en-US"/>
+              <a:rPr lang="en-US" smtClean="0"/>
               <a:t>Click to edit Master text styles</a:t>
             </a:r>
           </a:p>
           <a:p>
             <a:pPr lvl="1"/>
             <a:r>
-              <a:rPr lang="en-US"/>
+              <a:rPr lang="en-US" smtClean="0"/>
               <a:t>Second level</a:t>
             </a:r>
           </a:p>
           <a:p>
             <a:pPr lvl="2"/>
             <a:r>
-              <a:rPr lang="en-US"/>
+              <a:rPr lang="en-US" smtClean="0"/>
               <a:t>Third level</a:t>
             </a:r>
           </a:p>
           <a:p>
             <a:pPr lvl="3"/>
             <a:r>
-              <a:rPr lang="en-US"/>
+              <a:rPr lang="en-US" smtClean="0"/>
               <a:t>Fourth level</a:t>
             </a:r>
           </a:p>
           <a:p>
             <a:pPr lvl="4"/>
             <a:r>
-              <a:rPr lang="en-US"/>
+              <a:rPr lang="en-US" smtClean="0"/>
               <a:t>Fifth level</a:t>
             </a:r>
+            <a:endParaRPr lang="en-US"/>
           </a:p>
         </p:txBody>
       </p:sp>
@@ -2233,7 +2235,7 @@
           <a:p>
             <a:pPr lvl="0"/>
             <a:r>
-              <a:rPr lang="en-US"/>
+              <a:rPr lang="en-US" smtClean="0"/>
               <a:t>Click to edit Master text styles</a:t>
             </a:r>
           </a:p>
@@ -2256,7 +2258,7 @@
           <a:p>
             <a:fld id="{5BCAD085-E8A6-8845-BD4E-CB4CCA059FC4}" type="datetimeFigureOut">
               <a:rPr lang="en-US" smtClean="0"/>
-              <a:t>5/2/26</a:t>
+              <a:t>1/27/13</a:t>
             </a:fld>
             <a:endParaRPr lang="en-US"/>
           </a:p>
@@ -2359,9 +2361,10 @@
           </a:lstStyle>
           <a:p>
             <a:r>
-              <a:rPr lang="en-US"/>
+              <a:rPr lang="en-US" smtClean="0"/>
               <a:t>Click to edit Master title style</a:t>
             </a:r>
+            <a:endParaRPr lang="en-US"/>
           </a:p>
         </p:txBody>
       </p:sp>
@@ -2485,7 +2488,7 @@
           <a:p>
             <a:pPr lvl="0"/>
             <a:r>
-              <a:rPr lang="en-US"/>
+              <a:rPr lang="en-US" smtClean="0"/>
               <a:t>Click to edit Master text styles</a:t>
             </a:r>
           </a:p>
@@ -2508,7 +2511,7 @@
           <a:p>
             <a:fld id="{5BCAD085-E8A6-8845-BD4E-CB4CCA059FC4}" type="datetimeFigureOut">
               <a:rPr lang="en-US" smtClean="0"/>
-              <a:t>5/2/26</a:t>
+              <a:t>1/27/13</a:t>
             </a:fld>
             <a:endParaRPr lang="en-US"/>
           </a:p>
@@ -2617,9 +2620,10 @@
           <a:lstStyle/>
           <a:p>
             <a:r>
-              <a:rPr lang="en-US"/>
+              <a:rPr lang="en-US" smtClean="0"/>
               <a:t>Click to edit Master title style</a:t>
             </a:r>
+            <a:endParaRPr lang="en-US"/>
           </a:p>
         </p:txBody>
       </p:sp>
@@ -2650,37 +2654,38 @@
           <a:p>
             <a:pPr lvl="0"/>
             <a:r>
-              <a:rPr lang="en-US"/>
+              <a:rPr lang="en-US" smtClean="0"/>
               <a:t>Click to edit Master text styles</a:t>
             </a:r>
           </a:p>
           <a:p>
             <a:pPr lvl="1"/>
             <a:r>
-              <a:rPr lang="en-US"/>
+              <a:rPr lang="en-US" smtClean="0"/>
               <a:t>Second level</a:t>
             </a:r>
           </a:p>
           <a:p>
             <a:pPr lvl="2"/>
             <a:r>
-              <a:rPr lang="en-US"/>
+              <a:rPr lang="en-US" smtClean="0"/>
               <a:t>Third level</a:t>
             </a:r>
           </a:p>
           <a:p>
             <a:pPr lvl="3"/>
             <a:r>
-              <a:rPr lang="en-US"/>
+              <a:rPr lang="en-US" smtClean="0"/>
               <a:t>Fourth level</a:t>
             </a:r>
           </a:p>
           <a:p>
             <a:pPr lvl="4"/>
             <a:r>
-              <a:rPr lang="en-US"/>
+              <a:rPr lang="en-US" smtClean="0"/>
               <a:t>Fifth level</a:t>
             </a:r>
+            <a:endParaRPr lang="en-US"/>
           </a:p>
         </p:txBody>
       </p:sp>
@@ -2719,7 +2724,7 @@
           <a:p>
             <a:fld id="{5BCAD085-E8A6-8845-BD4E-CB4CCA059FC4}" type="datetimeFigureOut">
               <a:rPr lang="en-US" smtClean="0"/>
-              <a:t>5/2/26</a:t>
+              <a:t>1/27/13</a:t>
             </a:fld>
             <a:endParaRPr lang="en-US"/>
           </a:p>
@@ -3078,7 +3083,7 @@
 </file>
 
 <file path=ppt/slides/slide1.xml><?xml version="1.0" encoding="utf-8"?>
-<p:sld xmlns:a="http://schemas.openxmlformats.org/drawingml/2006/main" xmlns:r="http://schemas.openxmlformats.org/officeDocument/2006/relationships" xmlns:p="http://schemas.openxmlformats.org/presentationml/2006/main">
+<p:sld xmlns:a="http://schemas.openxmlformats.org/drawingml/2006/main" xmlns:p="http://schemas.openxmlformats.org/presentationml/2006/main" xmlns:r="http://schemas.openxmlformats.org/officeDocument/2006/relationships">
   <p:cSld>
     <p:spTree>
       <p:nvGrpSpPr>
@@ -3086,14 +3091,7 @@
         <p:cNvGrpSpPr/>
         <p:nvPr/>
       </p:nvGrpSpPr>
-      <p:grpSpPr>
-        <a:xfrm>
-          <a:off x="0" y="0"/>
-          <a:ext cx="0" cy="0"/>
-          <a:chOff x="0" y="0"/>
-          <a:chExt cx="0" cy="0"/>
-        </a:xfrm>
-      </p:grpSpPr>
+      <p:grpSpPr/>
       <p:sp>
         <p:nvSpPr>
           <p:cNvPr id="2" name="Rectangle 1"/>
@@ -3134,7 +3132,6 @@
           <a:lstStyle/>
           <a:p>
             <a:pPr algn="ctr"/>
-            <a:endParaRPr/>
           </a:p>
         </p:txBody>
       </p:sp>
@@ -3178,7 +3175,6 @@
           <a:lstStyle/>
           <a:p>
             <a:pPr algn="ctr"/>
-            <a:endParaRPr/>
           </a:p>
         </p:txBody>
       </p:sp>
@@ -3222,7 +3218,6 @@
           <a:lstStyle/>
           <a:p>
             <a:pPr algn="ctr"/>
-            <a:endParaRPr/>
           </a:p>
         </p:txBody>
       </p:sp>
@@ -3266,7 +3261,6 @@
           <a:lstStyle/>
           <a:p>
             <a:pPr algn="ctr"/>
-            <a:endParaRPr/>
           </a:p>
         </p:txBody>
       </p:sp>
@@ -3449,7 +3443,7 @@
 </file>
 
 <file path=ppt/slides/slide2.xml><?xml version="1.0" encoding="utf-8"?>
-<p:sld xmlns:a="http://schemas.openxmlformats.org/drawingml/2006/main" xmlns:r="http://schemas.openxmlformats.org/officeDocument/2006/relationships" xmlns:p="http://schemas.openxmlformats.org/presentationml/2006/main">
+<p:sld xmlns:a="http://schemas.openxmlformats.org/drawingml/2006/main" xmlns:p="http://schemas.openxmlformats.org/presentationml/2006/main" xmlns:r="http://schemas.openxmlformats.org/officeDocument/2006/relationships">
   <p:cSld>
     <p:spTree>
       <p:nvGrpSpPr>
@@ -3457,14 +3451,7 @@
         <p:cNvGrpSpPr/>
         <p:nvPr/>
       </p:nvGrpSpPr>
-      <p:grpSpPr>
-        <a:xfrm>
-          <a:off x="0" y="0"/>
-          <a:ext cx="0" cy="0"/>
-          <a:chOff x="0" y="0"/>
-          <a:chExt cx="0" cy="0"/>
-        </a:xfrm>
-      </p:grpSpPr>
+      <p:grpSpPr/>
       <p:sp>
         <p:nvSpPr>
           <p:cNvPr id="2" name="Rectangle 1"/>
@@ -3505,7 +3492,6 @@
           <a:lstStyle/>
           <a:p>
             <a:pPr algn="ctr"/>
-            <a:endParaRPr/>
           </a:p>
         </p:txBody>
       </p:sp>
@@ -3549,7 +3535,6 @@
           <a:lstStyle/>
           <a:p>
             <a:pPr algn="ctr"/>
-            <a:endParaRPr/>
           </a:p>
         </p:txBody>
       </p:sp>
@@ -3593,7 +3578,6 @@
           <a:lstStyle/>
           <a:p>
             <a:pPr algn="ctr"/>
-            <a:endParaRPr/>
           </a:p>
         </p:txBody>
       </p:sp>
@@ -3705,7 +3689,6 @@
           <a:lstStyle/>
           <a:p>
             <a:pPr algn="ctr"/>
-            <a:endParaRPr/>
           </a:p>
         </p:txBody>
       </p:sp>
@@ -3819,7 +3802,7 @@
         </p:nvSpPr>
         <p:spPr>
           <a:xfrm>
-            <a:off x="365760" y="2686884"/>
+            <a:off x="365760" y="2340864"/>
             <a:ext cx="5212080" cy="274320"/>
           </a:xfrm>
           <a:prstGeom prst="rect">
@@ -3851,7 +3834,6 @@
           <a:lstStyle/>
           <a:p>
             <a:pPr algn="ctr"/>
-            <a:endParaRPr/>
           </a:p>
         </p:txBody>
       </p:sp>
@@ -3863,8 +3845,8 @@
         </p:nvSpPr>
         <p:spPr>
           <a:xfrm>
-            <a:off x="475488" y="2723460"/>
-            <a:ext cx="5102352" cy="246221"/>
+            <a:off x="475488" y="2377440"/>
+            <a:ext cx="5102352" cy="237744"/>
           </a:xfrm>
           <a:prstGeom prst="rect">
             <a:avLst/>
@@ -3897,7 +3879,7 @@
         </p:nvSpPr>
         <p:spPr>
           <a:xfrm>
-            <a:off x="365760" y="2976372"/>
+            <a:off x="365760" y="2624328"/>
             <a:ext cx="5212080" cy="621792"/>
           </a:xfrm>
           <a:prstGeom prst="rect">
@@ -3913,7 +3895,7 @@
           <a:p>
             <a:pPr algn="l"/>
             <a:r>
-              <a:rPr sz="1300" b="0" i="0" dirty="0">
+              <a:rPr sz="1300" b="0" i="0">
                 <a:solidFill>
                   <a:srgbClr val="5A5F6E"/>
                 </a:solidFill>
@@ -3963,7 +3945,6 @@
           <a:lstStyle/>
           <a:p>
             <a:pPr algn="ctr"/>
-            <a:endParaRPr/>
           </a:p>
         </p:txBody>
       </p:sp>
@@ -4148,7 +4129,6 @@
           <a:lstStyle/>
           <a:p>
             <a:pPr algn="ctr"/>
-            <a:endParaRPr/>
           </a:p>
         </p:txBody>
       </p:sp>
@@ -4161,7 +4141,7 @@
 </file>
 
 <file path=ppt/slides/slide3.xml><?xml version="1.0" encoding="utf-8"?>
-<p:sld xmlns:a="http://schemas.openxmlformats.org/drawingml/2006/main" xmlns:r="http://schemas.openxmlformats.org/officeDocument/2006/relationships" xmlns:p="http://schemas.openxmlformats.org/presentationml/2006/main">
+<p:sld xmlns:a="http://schemas.openxmlformats.org/drawingml/2006/main" xmlns:p="http://schemas.openxmlformats.org/presentationml/2006/main" xmlns:r="http://schemas.openxmlformats.org/officeDocument/2006/relationships">
   <p:cSld>
     <p:spTree>
       <p:nvGrpSpPr>
@@ -4169,14 +4149,7 @@
         <p:cNvGrpSpPr/>
         <p:nvPr/>
       </p:nvGrpSpPr>
-      <p:grpSpPr>
-        <a:xfrm>
-          <a:off x="0" y="0"/>
-          <a:ext cx="0" cy="0"/>
-          <a:chOff x="0" y="0"/>
-          <a:chExt cx="0" cy="0"/>
-        </a:xfrm>
-      </p:grpSpPr>
+      <p:grpSpPr/>
       <p:sp>
         <p:nvSpPr>
           <p:cNvPr id="2" name="Rectangle 1"/>
@@ -4217,7 +4190,6 @@
           <a:lstStyle/>
           <a:p>
             <a:pPr algn="ctr"/>
-            <a:endParaRPr/>
           </a:p>
         </p:txBody>
       </p:sp>
@@ -4261,7 +4233,6 @@
           <a:lstStyle/>
           <a:p>
             <a:pPr algn="ctr"/>
-            <a:endParaRPr/>
           </a:p>
         </p:txBody>
       </p:sp>
@@ -4305,7 +4276,6 @@
           <a:lstStyle/>
           <a:p>
             <a:pPr algn="ctr"/>
-            <a:endParaRPr/>
           </a:p>
         </p:txBody>
       </p:sp>
@@ -4419,7 +4389,6 @@
           <a:lstStyle/>
           <a:p>
             <a:pPr algn="ctr"/>
-            <a:endParaRPr/>
           </a:p>
         </p:txBody>
       </p:sp>
@@ -4532,7 +4501,6 @@
           <a:lstStyle/>
           <a:p>
             <a:pPr algn="ctr"/>
-            <a:endParaRPr/>
           </a:p>
         </p:txBody>
       </p:sp>
@@ -4612,7 +4580,6 @@
           <a:lstStyle/>
           <a:p>
             <a:pPr algn="ctr"/>
-            <a:endParaRPr/>
           </a:p>
         </p:txBody>
       </p:sp>
@@ -4724,7 +4691,6 @@
           <a:lstStyle/>
           <a:p>
             <a:pPr algn="ctr"/>
-            <a:endParaRPr/>
           </a:p>
         </p:txBody>
       </p:sp>
@@ -4757,7 +4723,7 @@
                   <a:srgbClr val="FFFFFF"/>
                 </a:solidFill>
               </a:rPr>
-              <a:t>Challenge 2 — News API Ordering Bug</a:t>
+              <a:t>Challenge 2 — Data Pipeline Gap + News API Bug</a:t>
             </a:r>
           </a:p>
         </p:txBody>
@@ -4804,7 +4770,6 @@
           <a:lstStyle/>
           <a:p>
             <a:pPr algn="ctr"/>
-            <a:endParaRPr/>
           </a:p>
         </p:txBody>
       </p:sp>
@@ -4837,7 +4802,7 @@
                   <a:srgbClr val="5A5F6E"/>
                 </a:solidFill>
               </a:rPr>
-              <a:t>Problem: yfinance returns news chronologically-latest first, then filters by date. Running in 2026 with a 2024 date filter returned zero results — the filter ran after the API cutoff, not before.</a:t>
+              <a:t>Problem: Paper's experiments used a curated dataset (Bloomberg, EODHD, FinnHub, Reddit) — not released with the code. The open-source fallback, yfinance, returns 2025–26 articles when queried in 2026, leaving the News Analyst with zero relevant input for a Jan 2024 backtest.</a:t>
             </a:r>
           </a:p>
         </p:txBody>
@@ -4916,7 +4881,6 @@
           <a:lstStyle/>
           <a:p>
             <a:pPr algn="ctr"/>
-            <a:endParaRPr/>
           </a:p>
         </p:txBody>
       </p:sp>
@@ -4996,7 +4960,6 @@
           <a:lstStyle/>
           <a:p>
             <a:pPr algn="ctr"/>
-            <a:endParaRPr/>
           </a:p>
         </p:txBody>
       </p:sp>
@@ -5110,7 +5073,6 @@
           <a:lstStyle/>
           <a:p>
             <a:pPr algn="ctr"/>
-            <a:endParaRPr/>
           </a:p>
         </p:txBody>
       </p:sp>
@@ -5157,7 +5119,7 @@
 </file>
 
 <file path=ppt/slides/slide4.xml><?xml version="1.0" encoding="utf-8"?>
-<p:sld xmlns:a="http://schemas.openxmlformats.org/drawingml/2006/main" xmlns:r="http://schemas.openxmlformats.org/officeDocument/2006/relationships" xmlns:p="http://schemas.openxmlformats.org/presentationml/2006/main">
+<p:sld xmlns:a="http://schemas.openxmlformats.org/drawingml/2006/main" xmlns:p="http://schemas.openxmlformats.org/presentationml/2006/main" xmlns:r="http://schemas.openxmlformats.org/officeDocument/2006/relationships">
   <p:cSld>
     <p:spTree>
       <p:nvGrpSpPr>
@@ -5165,14 +5127,7 @@
         <p:cNvGrpSpPr/>
         <p:nvPr/>
       </p:nvGrpSpPr>
-      <p:grpSpPr>
-        <a:xfrm>
-          <a:off x="0" y="0"/>
-          <a:ext cx="0" cy="0"/>
-          <a:chOff x="0" y="0"/>
-          <a:chExt cx="0" cy="0"/>
-        </a:xfrm>
-      </p:grpSpPr>
+      <p:grpSpPr/>
       <p:sp>
         <p:nvSpPr>
           <p:cNvPr id="2" name="Rectangle 1"/>
@@ -5181,7 +5136,7 @@
         </p:nvSpPr>
         <p:spPr>
           <a:xfrm>
-            <a:off x="0" y="301083"/>
+            <a:off x="0" y="0"/>
             <a:ext cx="12191695" cy="6858000"/>
           </a:xfrm>
           <a:prstGeom prst="rect">
@@ -5213,7 +5168,6 @@
           <a:lstStyle/>
           <a:p>
             <a:pPr algn="ctr"/>
-            <a:endParaRPr/>
           </a:p>
         </p:txBody>
       </p:sp>
@@ -5257,7 +5211,6 @@
           <a:lstStyle/>
           <a:p>
             <a:pPr algn="ctr"/>
-            <a:endParaRPr/>
           </a:p>
         </p:txBody>
       </p:sp>
@@ -5301,7 +5254,6 @@
           <a:lstStyle/>
           <a:p>
             <a:pPr algn="ctr"/>
-            <a:endParaRPr/>
           </a:p>
         </p:txBody>
       </p:sp>
@@ -5413,7 +5365,6 @@
           <a:lstStyle/>
           <a:p>
             <a:pPr algn="ctr"/>
-            <a:endParaRPr/>
           </a:p>
         </p:txBody>
       </p:sp>
@@ -5491,7 +5442,6 @@
           <a:lstStyle/>
           <a:p>
             <a:pPr algn="ctr"/>
-            <a:endParaRPr/>
           </a:p>
         </p:txBody>
       </p:sp>
@@ -5519,7 +5469,7 @@
           <a:p>
             <a:pPr algn="ctr"/>
             <a:r>
-              <a:rPr sz="1000" b="1" i="0" dirty="0">
+              <a:rPr sz="1000" b="1" i="0">
                 <a:solidFill>
                   <a:srgbClr val="FFFFFF"/>
                 </a:solidFill>
@@ -5569,7 +5519,6 @@
           <a:lstStyle/>
           <a:p>
             <a:pPr algn="ctr"/>
-            <a:endParaRPr/>
           </a:p>
         </p:txBody>
       </p:sp>
@@ -5647,7 +5596,6 @@
           <a:lstStyle/>
           <a:p>
             <a:pPr algn="ctr"/>
-            <a:endParaRPr/>
           </a:p>
         </p:txBody>
       </p:sp>
@@ -5725,7 +5673,6 @@
           <a:lstStyle/>
           <a:p>
             <a:pPr algn="ctr"/>
-            <a:endParaRPr/>
           </a:p>
         </p:txBody>
       </p:sp>
@@ -5805,7 +5752,6 @@
           <a:lstStyle/>
           <a:p>
             <a:pPr algn="ctr"/>
-            <a:endParaRPr/>
           </a:p>
         </p:txBody>
       </p:sp>
@@ -5885,7 +5831,6 @@
           <a:lstStyle/>
           <a:p>
             <a:pPr algn="ctr"/>
-            <a:endParaRPr/>
           </a:p>
         </p:txBody>
       </p:sp>
@@ -5965,7 +5910,6 @@
           <a:lstStyle/>
           <a:p>
             <a:pPr algn="ctr"/>
-            <a:endParaRPr/>
           </a:p>
         </p:txBody>
       </p:sp>
@@ -6045,7 +5989,6 @@
           <a:lstStyle/>
           <a:p>
             <a:pPr algn="ctr"/>
-            <a:endParaRPr/>
           </a:p>
         </p:txBody>
       </p:sp>
@@ -6125,7 +6068,6 @@
           <a:lstStyle/>
           <a:p>
             <a:pPr algn="ctr"/>
-            <a:endParaRPr/>
           </a:p>
         </p:txBody>
       </p:sp>
@@ -6205,7 +6147,6 @@
           <a:lstStyle/>
           <a:p>
             <a:pPr algn="ctr"/>
-            <a:endParaRPr/>
           </a:p>
         </p:txBody>
       </p:sp>
@@ -6285,7 +6226,6 @@
           <a:lstStyle/>
           <a:p>
             <a:pPr algn="ctr"/>
-            <a:endParaRPr/>
           </a:p>
         </p:txBody>
       </p:sp>
@@ -6365,7 +6305,6 @@
           <a:lstStyle/>
           <a:p>
             <a:pPr algn="ctr"/>
-            <a:endParaRPr/>
           </a:p>
         </p:txBody>
       </p:sp>
@@ -6445,7 +6384,6 @@
           <a:lstStyle/>
           <a:p>
             <a:pPr algn="ctr"/>
-            <a:endParaRPr/>
           </a:p>
         </p:txBody>
       </p:sp>
@@ -6525,7 +6463,6 @@
           <a:lstStyle/>
           <a:p>
             <a:pPr algn="ctr"/>
-            <a:endParaRPr/>
           </a:p>
         </p:txBody>
       </p:sp>
@@ -6605,7 +6542,6 @@
           <a:lstStyle/>
           <a:p>
             <a:pPr algn="ctr"/>
-            <a:endParaRPr/>
           </a:p>
         </p:txBody>
       </p:sp>
@@ -6685,7 +6621,6 @@
           <a:lstStyle/>
           <a:p>
             <a:pPr algn="ctr"/>
-            <a:endParaRPr/>
           </a:p>
         </p:txBody>
       </p:sp>
@@ -6765,7 +6700,6 @@
           <a:lstStyle/>
           <a:p>
             <a:pPr algn="ctr"/>
-            <a:endParaRPr/>
           </a:p>
         </p:txBody>
       </p:sp>
@@ -6845,7 +6779,6 @@
           <a:lstStyle/>
           <a:p>
             <a:pPr algn="ctr"/>
-            <a:endParaRPr/>
           </a:p>
         </p:txBody>
       </p:sp>
@@ -6925,7 +6858,6 @@
           <a:lstStyle/>
           <a:p>
             <a:pPr algn="ctr"/>
-            <a:endParaRPr/>
           </a:p>
         </p:txBody>
       </p:sp>
@@ -7005,7 +6937,6 @@
           <a:lstStyle/>
           <a:p>
             <a:pPr algn="ctr"/>
-            <a:endParaRPr/>
           </a:p>
         </p:txBody>
       </p:sp>
@@ -7085,7 +7016,6 @@
           <a:lstStyle/>
           <a:p>
             <a:pPr algn="ctr"/>
-            <a:endParaRPr/>
           </a:p>
         </p:txBody>
       </p:sp>
@@ -7165,7 +7095,6 @@
           <a:lstStyle/>
           <a:p>
             <a:pPr algn="ctr"/>
-            <a:endParaRPr/>
           </a:p>
         </p:txBody>
       </p:sp>
@@ -7245,7 +7174,6 @@
           <a:lstStyle/>
           <a:p>
             <a:pPr algn="ctr"/>
-            <a:endParaRPr/>
           </a:p>
         </p:txBody>
       </p:sp>
@@ -7325,7 +7253,6 @@
           <a:lstStyle/>
           <a:p>
             <a:pPr algn="ctr"/>
-            <a:endParaRPr/>
           </a:p>
         </p:txBody>
       </p:sp>
@@ -7405,7 +7332,6 @@
           <a:lstStyle/>
           <a:p>
             <a:pPr algn="ctr"/>
-            <a:endParaRPr/>
           </a:p>
         </p:txBody>
       </p:sp>
@@ -7485,7 +7411,6 @@
           <a:lstStyle/>
           <a:p>
             <a:pPr algn="ctr"/>
-            <a:endParaRPr/>
           </a:p>
         </p:txBody>
       </p:sp>
@@ -7565,7 +7490,6 @@
           <a:lstStyle/>
           <a:p>
             <a:pPr algn="ctr"/>
-            <a:endParaRPr/>
           </a:p>
         </p:txBody>
       </p:sp>
@@ -7645,7 +7569,6 @@
           <a:lstStyle/>
           <a:p>
             <a:pPr algn="ctr"/>
-            <a:endParaRPr/>
           </a:p>
         </p:txBody>
       </p:sp>
@@ -7725,7 +7648,6 @@
           <a:lstStyle/>
           <a:p>
             <a:pPr algn="ctr"/>
-            <a:endParaRPr/>
           </a:p>
         </p:txBody>
       </p:sp>
@@ -7805,7 +7727,6 @@
           <a:lstStyle/>
           <a:p>
             <a:pPr algn="ctr"/>
-            <a:endParaRPr/>
           </a:p>
         </p:txBody>
       </p:sp>
@@ -7900,7 +7821,7 @@
 </file>
 
 <file path=ppt/slides/slide5.xml><?xml version="1.0" encoding="utf-8"?>
-<p:sld xmlns:a="http://schemas.openxmlformats.org/drawingml/2006/main" xmlns:r="http://schemas.openxmlformats.org/officeDocument/2006/relationships" xmlns:p="http://schemas.openxmlformats.org/presentationml/2006/main">
+<p:sld xmlns:a="http://schemas.openxmlformats.org/drawingml/2006/main" xmlns:p="http://schemas.openxmlformats.org/presentationml/2006/main" xmlns:r="http://schemas.openxmlformats.org/officeDocument/2006/relationships">
   <p:cSld>
     <p:spTree>
       <p:nvGrpSpPr>
@@ -7908,14 +7829,7 @@
         <p:cNvGrpSpPr/>
         <p:nvPr/>
       </p:nvGrpSpPr>
-      <p:grpSpPr>
-        <a:xfrm>
-          <a:off x="0" y="0"/>
-          <a:ext cx="0" cy="0"/>
-          <a:chOff x="0" y="0"/>
-          <a:chExt cx="0" cy="0"/>
-        </a:xfrm>
-      </p:grpSpPr>
+      <p:grpSpPr/>
       <p:sp>
         <p:nvSpPr>
           <p:cNvPr id="2" name="Rectangle 1"/>
@@ -7956,7 +7870,6 @@
           <a:lstStyle/>
           <a:p>
             <a:pPr algn="ctr"/>
-            <a:endParaRPr/>
           </a:p>
         </p:txBody>
       </p:sp>
@@ -8000,7 +7913,6 @@
           <a:lstStyle/>
           <a:p>
             <a:pPr algn="ctr"/>
-            <a:endParaRPr/>
           </a:p>
         </p:txBody>
       </p:sp>
@@ -8044,7 +7956,6 @@
           <a:lstStyle/>
           <a:p>
             <a:pPr algn="ctr"/>
-            <a:endParaRPr/>
           </a:p>
         </p:txBody>
       </p:sp>
@@ -8158,7 +8069,6 @@
           <a:lstStyle/>
           <a:p>
             <a:pPr algn="ctr"/>
-            <a:endParaRPr/>
           </a:p>
         </p:txBody>
       </p:sp>
@@ -8338,7 +8248,6 @@
           <a:lstStyle/>
           <a:p>
             <a:pPr algn="ctr"/>
-            <a:endParaRPr/>
           </a:p>
         </p:txBody>
       </p:sp>
@@ -8418,7 +8327,6 @@
           <a:lstStyle/>
           <a:p>
             <a:pPr algn="ctr"/>
-            <a:endParaRPr/>
           </a:p>
         </p:txBody>
       </p:sp>
@@ -8598,7 +8506,6 @@
           <a:lstStyle/>
           <a:p>
             <a:pPr algn="ctr"/>
-            <a:endParaRPr/>
           </a:p>
         </p:txBody>
       </p:sp>
@@ -8678,7 +8585,6 @@
           <a:lstStyle/>
           <a:p>
             <a:pPr algn="ctr"/>
-            <a:endParaRPr/>
           </a:p>
         </p:txBody>
       </p:sp>
@@ -8860,7 +8766,6 @@
           <a:lstStyle/>
           <a:p>
             <a:pPr algn="ctr"/>
-            <a:endParaRPr/>
           </a:p>
         </p:txBody>
       </p:sp>

</xml_diff>